<commit_message>
Update presentation slides 2204
</commit_message>
<xml_diff>
--- a/docs/presentations/Réuniond’avancement2204.pptx
+++ b/docs/presentations/Réuniond’avancement2204.pptx
@@ -9,6 +9,7 @@
     <p:sldId id="257" r:id="rId3"/>
     <p:sldId id="258" r:id="rId4"/>
     <p:sldId id="259" r:id="rId5"/>
+    <p:sldId id="260" r:id="rId6"/>
   </p:sldIdLst>
   <p:sldSz cx="12192000" cy="6858000"/>
   <p:notesSz cx="6858000" cy="9144000"/>
@@ -3474,6 +3475,12 @@
           <a:p>
             <a:r>
               <a:rPr lang="fr-FR" dirty="0"/>
+              <a:t>Problème: manque de vocabulaire donc certains mots mal traduits.</a:t>
+            </a:r>
+          </a:p>
+          <a:p>
+            <a:r>
+              <a:rPr lang="fr-FR" dirty="0"/>
               <a:t>5000 lignes.</a:t>
             </a:r>
           </a:p>
@@ -3630,11 +3637,7 @@
             <a:pPr lvl="1"/>
             <a:r>
               <a:rPr lang="fr-FR" dirty="0"/>
-              <a:t>Liste des mots associés à un signe mais compliqué à exploiter, peut-être créer liste des mots autorisés, mais dans ce cas là, comment choisir par quel mot autorisé remplacer un </a:t>
-            </a:r>
-            <a:r>
-              <a:rPr lang="fr-FR"/>
-              <a:t>mot non-traductible.</a:t>
+              <a:t>Liste des mots associés à un signe mais compliqué à exploiter, peut-être créer liste des mots autorisés, mais dans ce cas là, comment choisir par quel mot autorisé remplacer un mot non-traductible.</a:t>
             </a:r>
           </a:p>
           <a:p>
@@ -3662,6 +3665,13 @@
             <a:r>
               <a:rPr lang="fr-FR" dirty="0"/>
               <a:t>NEW: OPPOSITION LISTUM LOI DEMANDER</a:t>
+            </a:r>
+          </a:p>
+          <a:p>
+            <a:pPr lvl="1"/>
+            <a:r>
+              <a:rPr lang="fr-FR" dirty="0"/>
+              <a:t>Avancées lentes car « à la main », ajout progressif de vocabulaire, peut-être changer de modèle ?</a:t>
             </a:r>
           </a:p>
           <a:p>
@@ -3763,15 +3773,37 @@
           <a:p>
             <a:r>
               <a:rPr lang="fr-FR" dirty="0"/>
-              <a:t>Avec 20k lignes d’entrainement, 12h nécessaires sur </a:t>
-            </a:r>
-            <a:r>
-              <a:rPr lang="fr-FR"/>
-              <a:t>notre machine.</a:t>
-            </a:r>
-          </a:p>
-          <a:p>
-            <a:endParaRPr lang="fr-FR"/>
+              <a:t>Avec 20k lignes d’entrainement, 12h nécessaires sur notre machine.</a:t>
+            </a:r>
+          </a:p>
+          <a:p>
+            <a:r>
+              <a:rPr lang="fr-FR" dirty="0"/>
+              <a:t>Accès à une machine virtuelle avec </a:t>
+            </a:r>
+            <a:r>
+              <a:rPr lang="fr-FR" dirty="0" err="1"/>
+              <a:t>Hubia</a:t>
+            </a:r>
+            <a:r>
+              <a:rPr lang="fr-FR" dirty="0"/>
+              <a:t> à CS, il faut faire une demande de création de compte.</a:t>
+            </a:r>
+          </a:p>
+          <a:p>
+            <a:r>
+              <a:rPr lang="fr-FR" dirty="0">
+                <a:hlinkClick r:id="rId2"/>
+              </a:rPr>
+              <a:t>https://hubia_dgx.pages.centralesupelec.fr/</a:t>
+            </a:r>
+            <a:endParaRPr lang="fr-FR" dirty="0"/>
+          </a:p>
+          <a:p>
+            <a:endParaRPr lang="fr-FR" dirty="0"/>
+          </a:p>
+          <a:p>
+            <a:endParaRPr lang="fr-FR" dirty="0"/>
           </a:p>
         </p:txBody>
       </p:sp>
@@ -3779,6 +3811,117 @@
     <p:extLst>
       <p:ext uri="{BB962C8B-B14F-4D97-AF65-F5344CB8AC3E}">
         <p14:creationId xmlns:p14="http://schemas.microsoft.com/office/powerpoint/2010/main" val="3513071932"/>
+      </p:ext>
+    </p:extLst>
+  </p:cSld>
+  <p:clrMapOvr>
+    <a:masterClrMapping/>
+  </p:clrMapOvr>
+</p:sld>
+</file>
+
+<file path=ppt/slides/slide5.xml><?xml version="1.0" encoding="utf-8"?>
+<p:sld xmlns:a="http://schemas.openxmlformats.org/drawingml/2006/main" xmlns:r="http://schemas.openxmlformats.org/officeDocument/2006/relationships" xmlns:p="http://schemas.openxmlformats.org/presentationml/2006/main">
+  <p:cSld>
+    <p:spTree>
+      <p:nvGrpSpPr>
+        <p:cNvPr id="1" name=""/>
+        <p:cNvGrpSpPr/>
+        <p:nvPr/>
+      </p:nvGrpSpPr>
+      <p:grpSpPr>
+        <a:xfrm>
+          <a:off x="0" y="0"/>
+          <a:ext cx="0" cy="0"/>
+          <a:chOff x="0" y="0"/>
+          <a:chExt cx="0" cy="0"/>
+        </a:xfrm>
+      </p:grpSpPr>
+      <p:sp>
+        <p:nvSpPr>
+          <p:cNvPr id="2" name="Titre 1">
+            <a:extLst>
+              <a:ext uri="{FF2B5EF4-FFF2-40B4-BE49-F238E27FC236}">
+                <a16:creationId xmlns:a16="http://schemas.microsoft.com/office/drawing/2014/main" id="{E85BDA33-7772-6636-24F0-891C1B814C4E}"/>
+              </a:ext>
+            </a:extLst>
+          </p:cNvPr>
+          <p:cNvSpPr>
+            <a:spLocks noGrp="1"/>
+          </p:cNvSpPr>
+          <p:nvPr>
+            <p:ph type="title"/>
+          </p:nvPr>
+        </p:nvSpPr>
+        <p:spPr/>
+        <p:txBody>
+          <a:bodyPr/>
+          <a:lstStyle/>
+          <a:p>
+            <a:r>
+              <a:rPr lang="fr-FR" dirty="0"/>
+              <a:t>Résumé</a:t>
+            </a:r>
+          </a:p>
+        </p:txBody>
+      </p:sp>
+      <p:sp>
+        <p:nvSpPr>
+          <p:cNvPr id="3" name="Espace réservé du contenu 2">
+            <a:extLst>
+              <a:ext uri="{FF2B5EF4-FFF2-40B4-BE49-F238E27FC236}">
+                <a16:creationId xmlns:a16="http://schemas.microsoft.com/office/drawing/2014/main" id="{9C72C98E-E687-9FA1-66A0-C5CB9D702523}"/>
+              </a:ext>
+            </a:extLst>
+          </p:cNvPr>
+          <p:cNvSpPr>
+            <a:spLocks noGrp="1"/>
+          </p:cNvSpPr>
+          <p:nvPr>
+            <p:ph idx="1"/>
+          </p:nvPr>
+        </p:nvSpPr>
+        <p:spPr/>
+        <p:txBody>
+          <a:bodyPr/>
+          <a:lstStyle/>
+          <a:p>
+            <a:r>
+              <a:rPr lang="fr-FR" dirty="0"/>
+              <a:t>Prochaines étapes: </a:t>
+            </a:r>
+          </a:p>
+          <a:p>
+            <a:pPr lvl="1"/>
+            <a:r>
+              <a:rPr lang="fr-FR" dirty="0"/>
+              <a:t>demande de machine virtuelle.</a:t>
+            </a:r>
+          </a:p>
+          <a:p>
+            <a:pPr lvl="1"/>
+            <a:r>
+              <a:rPr lang="fr-FR" dirty="0"/>
+              <a:t>explorer un nouveau modèle/solution pour le problème de vocabulaire.</a:t>
+            </a:r>
+          </a:p>
+          <a:p>
+            <a:pPr lvl="1"/>
+            <a:r>
+              <a:rPr lang="fr-FR" dirty="0"/>
+              <a:t>trouver une méthode pour déterminer quels mots ‘existent’ en LSF et l’intégrer au modèle.</a:t>
+            </a:r>
+          </a:p>
+          <a:p>
+            <a:pPr lvl="1"/>
+            <a:endParaRPr lang="fr-FR" dirty="0"/>
+          </a:p>
+        </p:txBody>
+      </p:sp>
+    </p:spTree>
+    <p:extLst>
+      <p:ext uri="{BB962C8B-B14F-4D97-AF65-F5344CB8AC3E}">
+        <p14:creationId xmlns:p14="http://schemas.microsoft.com/office/powerpoint/2010/main" val="2364833080"/>
       </p:ext>
     </p:extLst>
   </p:cSld>

</xml_diff>